<commit_message>
presentation for the third SC meeting
</commit_message>
<xml_diff>
--- a/assets/slide-header.pptx
+++ b/assets/slide-header.pptx
@@ -5,19 +5,20 @@
     <p:sldMasterId id="2147483648" r:id="rId1"/>
   </p:sldMasterIdLst>
   <p:notesMasterIdLst>
-    <p:notesMasterId r:id="rId4"/>
+    <p:notesMasterId r:id="rId5"/>
   </p:notesMasterIdLst>
   <p:sldIdLst>
     <p:sldId id="256" r:id="rId2"/>
     <p:sldId id="257" r:id="rId3"/>
+    <p:sldId id="258" r:id="rId4"/>
   </p:sldIdLst>
   <p:sldSz cx="12192000" cy="6858000"/>
   <p:notesSz cx="6858000" cy="9144000"/>
   <p:embeddedFontLst>
     <p:embeddedFont>
       <p:font typeface="Play" pitchFamily="2" charset="0"/>
-      <p:regular r:id="rId5"/>
-      <p:bold r:id="rId6"/>
+      <p:regular r:id="rId6"/>
+      <p:bold r:id="rId7"/>
     </p:embeddedFont>
   </p:embeddedFontLst>
   <p:defaultTextStyle>
@@ -265,7 +266,7 @@
       </p15:sldGuideLst>
     </p:ext>
     <p:ext uri="GoogleSlidesCustomDataVersion2">
-      <go:slidesCustomData xmlns:go="http://customooxmlschemas.google.com/" xmlns:ahyp="http://schemas.microsoft.com/office/drawing/2018/hyperlinkcolor" xmlns:p15="http://schemas.microsoft.com/office/powerpoint/2012/main" xmlns:p14="http://schemas.microsoft.com/office/powerpoint/2010/main" xmlns:com="http://schemas.openxmlformats.org/drawingml/2006/compatibility" xmlns:pvml="urn:schemas-microsoft-com:office:powerpoint" xmlns:v="urn:schemas-microsoft-com:vml" xmlns:o="urn:schemas-microsoft-com:office:office" xmlns:dgm="http://schemas.openxmlformats.org/drawingml/2006/diagram" xmlns:c="http://schemas.openxmlformats.org/drawingml/2006/chart" xmlns:mv="urn:schemas-microsoft-com:mac:vml" xmlns:mc="http://schemas.openxmlformats.org/markup-compatibility/2006" xmlns="" r:id="rId26" roundtripDataSignature="AMtx7mh3xTX80LKrPPnQbE+I3JQN7wPtLA=="/>
+      <go:slidesCustomData xmlns="" xmlns:mc="http://schemas.openxmlformats.org/markup-compatibility/2006" xmlns:mv="urn:schemas-microsoft-com:mac:vml" xmlns:c="http://schemas.openxmlformats.org/drawingml/2006/chart" xmlns:dgm="http://schemas.openxmlformats.org/drawingml/2006/diagram" xmlns:o="urn:schemas-microsoft-com:office:office" xmlns:v="urn:schemas-microsoft-com:vml" xmlns:pvml="urn:schemas-microsoft-com:office:powerpoint" xmlns:com="http://schemas.openxmlformats.org/drawingml/2006/compatibility" xmlns:p14="http://schemas.microsoft.com/office/powerpoint/2010/main" xmlns:p15="http://schemas.microsoft.com/office/powerpoint/2012/main" xmlns:ahyp="http://schemas.microsoft.com/office/drawing/2018/hyperlinkcolor" xmlns:go="http://customooxmlschemas.google.com/" r:id="rId26" roundtripDataSignature="AMtx7mh3xTX80LKrPPnQbE+I3JQN7wPtLA=="/>
     </p:ext>
   </p:extLst>
 </p:presentation>
@@ -1812,6 +1813,199 @@
     <p:extLst>
       <p:ext uri="{BB962C8B-B14F-4D97-AF65-F5344CB8AC3E}">
         <p14:creationId xmlns:p14="http://schemas.microsoft.com/office/powerpoint/2010/main" val="2486129127"/>
+      </p:ext>
+    </p:extLst>
+  </p:cSld>
+  <p:clrMapOvr>
+    <a:masterClrMapping/>
+  </p:clrMapOvr>
+</p:notes>
+</file>
+
+<file path=ppt/notesSlides/notesSlide3.xml><?xml version="1.0" encoding="utf-8"?>
+<p:notes xmlns:a="http://schemas.openxmlformats.org/drawingml/2006/main" xmlns:r="http://schemas.openxmlformats.org/officeDocument/2006/relationships" xmlns:p="http://schemas.openxmlformats.org/presentationml/2006/main" showMasterSp="0" showMasterPhAnim="0">
+  <p:cSld>
+    <p:spTree>
+      <p:nvGrpSpPr>
+        <p:cNvPr id="1" name="Shape 84">
+          <a:extLst>
+            <a:ext uri="{FF2B5EF4-FFF2-40B4-BE49-F238E27FC236}">
+              <a16:creationId xmlns:a16="http://schemas.microsoft.com/office/drawing/2014/main" id="{3F2368F1-B3A1-4DA5-CE53-AF0E11F2B091}"/>
+            </a:ext>
+          </a:extLst>
+        </p:cNvPr>
+        <p:cNvGrpSpPr/>
+        <p:nvPr/>
+      </p:nvGrpSpPr>
+      <p:grpSpPr>
+        <a:xfrm>
+          <a:off x="0" y="0"/>
+          <a:ext cx="0" cy="0"/>
+          <a:chOff x="0" y="0"/>
+          <a:chExt cx="0" cy="0"/>
+        </a:xfrm>
+      </p:grpSpPr>
+      <p:sp>
+        <p:nvSpPr>
+          <p:cNvPr id="85" name="Google Shape;85;p1:notes">
+            <a:extLst>
+              <a:ext uri="{FF2B5EF4-FFF2-40B4-BE49-F238E27FC236}">
+                <a16:creationId xmlns:a16="http://schemas.microsoft.com/office/drawing/2014/main" id="{C2694674-1B73-EE24-9185-0907394BAF5D}"/>
+              </a:ext>
+            </a:extLst>
+          </p:cNvPr>
+          <p:cNvSpPr>
+            <a:spLocks noGrp="1" noRot="1" noChangeAspect="1"/>
+          </p:cNvSpPr>
+          <p:nvPr>
+            <p:ph type="sldImg" idx="2"/>
+          </p:nvPr>
+        </p:nvSpPr>
+        <p:spPr>
+          <a:xfrm>
+            <a:off x="685800" y="1143000"/>
+            <a:ext cx="5486400" cy="3086100"/>
+          </a:xfrm>
+          <a:custGeom>
+            <a:avLst/>
+            <a:gdLst/>
+            <a:ahLst/>
+            <a:cxnLst/>
+            <a:rect l="l" t="t" r="r" b="b"/>
+            <a:pathLst>
+              <a:path w="120000" h="120000" extrusionOk="0">
+                <a:moveTo>
+                  <a:pt x="0" y="0"/>
+                </a:moveTo>
+                <a:lnTo>
+                  <a:pt x="120000" y="0"/>
+                </a:lnTo>
+                <a:lnTo>
+                  <a:pt x="120000" y="120000"/>
+                </a:lnTo>
+                <a:lnTo>
+                  <a:pt x="0" y="120000"/>
+                </a:lnTo>
+                <a:close/>
+              </a:path>
+            </a:pathLst>
+          </a:custGeom>
+          <a:noFill/>
+          <a:ln w="12700" cap="flat" cmpd="sng">
+            <a:solidFill>
+              <a:srgbClr val="000000"/>
+            </a:solidFill>
+            <a:prstDash val="solid"/>
+            <a:round/>
+            <a:headEnd type="none" w="sm" len="sm"/>
+            <a:tailEnd type="none" w="sm" len="sm"/>
+          </a:ln>
+        </p:spPr>
+      </p:sp>
+      <p:sp>
+        <p:nvSpPr>
+          <p:cNvPr id="86" name="Google Shape;86;p1:notes">
+            <a:extLst>
+              <a:ext uri="{FF2B5EF4-FFF2-40B4-BE49-F238E27FC236}">
+                <a16:creationId xmlns:a16="http://schemas.microsoft.com/office/drawing/2014/main" id="{23473156-9F0F-7FFD-2A40-C77473C95F6A}"/>
+              </a:ext>
+            </a:extLst>
+          </p:cNvPr>
+          <p:cNvSpPr txBox="1">
+            <a:spLocks noGrp="1"/>
+          </p:cNvSpPr>
+          <p:nvPr>
+            <p:ph type="body" idx="1"/>
+          </p:nvPr>
+        </p:nvSpPr>
+        <p:spPr>
+          <a:xfrm>
+            <a:off x="685800" y="4400550"/>
+            <a:ext cx="5486400" cy="3600450"/>
+          </a:xfrm>
+          <a:prstGeom prst="rect">
+            <a:avLst/>
+          </a:prstGeom>
+          <a:noFill/>
+          <a:ln>
+            <a:noFill/>
+          </a:ln>
+        </p:spPr>
+        <p:txBody>
+          <a:bodyPr spcFirstLastPara="1" wrap="square" lIns="91425" tIns="45700" rIns="91425" bIns="45700" anchor="t" anchorCtr="0">
+            <a:noAutofit/>
+          </a:bodyPr>
+          <a:lstStyle/>
+          <a:p>
+            <a:pPr marL="0" lvl="0" indent="0" algn="l" rtl="0">
+              <a:spcBef>
+                <a:spcPts val="0"/>
+              </a:spcBef>
+              <a:spcAft>
+                <a:spcPts val="0"/>
+              </a:spcAft>
+              <a:buNone/>
+            </a:pPr>
+            <a:endParaRPr/>
+          </a:p>
+        </p:txBody>
+      </p:sp>
+      <p:sp>
+        <p:nvSpPr>
+          <p:cNvPr id="87" name="Google Shape;87;p1:notes">
+            <a:extLst>
+              <a:ext uri="{FF2B5EF4-FFF2-40B4-BE49-F238E27FC236}">
+                <a16:creationId xmlns:a16="http://schemas.microsoft.com/office/drawing/2014/main" id="{148887D6-B9EA-143E-FBED-AD9E269529C3}"/>
+              </a:ext>
+            </a:extLst>
+          </p:cNvPr>
+          <p:cNvSpPr txBox="1">
+            <a:spLocks noGrp="1"/>
+          </p:cNvSpPr>
+          <p:nvPr>
+            <p:ph type="sldNum" idx="12"/>
+          </p:nvPr>
+        </p:nvSpPr>
+        <p:spPr>
+          <a:xfrm>
+            <a:off x="3884613" y="8685213"/>
+            <a:ext cx="2971800" cy="458787"/>
+          </a:xfrm>
+          <a:prstGeom prst="rect">
+            <a:avLst/>
+          </a:prstGeom>
+          <a:noFill/>
+          <a:ln>
+            <a:noFill/>
+          </a:ln>
+        </p:spPr>
+        <p:txBody>
+          <a:bodyPr spcFirstLastPara="1" wrap="square" lIns="91425" tIns="45700" rIns="91425" bIns="45700" anchor="b" anchorCtr="0">
+            <a:noAutofit/>
+          </a:bodyPr>
+          <a:lstStyle/>
+          <a:p>
+            <a:pPr marL="0" lvl="0" indent="0" algn="r" rtl="0">
+              <a:spcBef>
+                <a:spcPts val="0"/>
+              </a:spcBef>
+              <a:spcAft>
+                <a:spcPts val="0"/>
+              </a:spcAft>
+              <a:buNone/>
+            </a:pPr>
+            <a:fld id="{00000000-1234-1234-1234-123412341234}" type="slidenum">
+              <a:rPr lang="en-US"/>
+              <a:t>3</a:t>
+            </a:fld>
+            <a:endParaRPr/>
+          </a:p>
+        </p:txBody>
+      </p:sp>
+    </p:spTree>
+    <p:extLst>
+      <p:ext uri="{BB962C8B-B14F-4D97-AF65-F5344CB8AC3E}">
+        <p14:creationId xmlns:p14="http://schemas.microsoft.com/office/powerpoint/2010/main" val="2451282374"/>
       </p:ext>
     </p:extLst>
   </p:cSld>
@@ -10957,10 +11151,10 @@
           <p:nvPr/>
         </p:nvPicPr>
         <p:blipFill>
-          <a:blip r:embed="rId13">
+          <a:blip>
             <a:extLst>
               <a:ext uri="{96DAC541-7B7A-43D3-8B79-37D633B846F1}">
-                <asvg:svgBlip xmlns:asvg="http://schemas.microsoft.com/office/drawing/2016/SVG/main" r:embed="rId14"/>
+                <asvg:svgBlip xmlns:asvg="http://schemas.microsoft.com/office/drawing/2016/SVG/main" r:embed="rId13"/>
               </a:ext>
             </a:extLst>
           </a:blip>
@@ -11193,6 +11387,309 @@
     <p:extLst>
       <p:ext uri="{BB962C8B-B14F-4D97-AF65-F5344CB8AC3E}">
         <p14:creationId xmlns:p14="http://schemas.microsoft.com/office/powerpoint/2010/main" val="1133551674"/>
+      </p:ext>
+    </p:extLst>
+  </p:cSld>
+  <p:clrMapOvr>
+    <a:masterClrMapping/>
+  </p:clrMapOvr>
+</p:sld>
+</file>
+
+<file path=ppt/slides/slide3.xml><?xml version="1.0" encoding="utf-8"?>
+<p:sld xmlns:a="http://schemas.openxmlformats.org/drawingml/2006/main" xmlns:r="http://schemas.openxmlformats.org/officeDocument/2006/relationships" xmlns:p="http://schemas.openxmlformats.org/presentationml/2006/main">
+  <p:cSld>
+    <p:spTree>
+      <p:nvGrpSpPr>
+        <p:cNvPr id="1" name="Shape 88">
+          <a:extLst>
+            <a:ext uri="{FF2B5EF4-FFF2-40B4-BE49-F238E27FC236}">
+              <a16:creationId xmlns:a16="http://schemas.microsoft.com/office/drawing/2014/main" id="{17E0FC92-F6F5-F93B-EC23-63CE85A17312}"/>
+            </a:ext>
+          </a:extLst>
+        </p:cNvPr>
+        <p:cNvGrpSpPr/>
+        <p:nvPr/>
+      </p:nvGrpSpPr>
+      <p:grpSpPr>
+        <a:xfrm>
+          <a:off x="0" y="0"/>
+          <a:ext cx="0" cy="0"/>
+          <a:chOff x="0" y="0"/>
+          <a:chExt cx="0" cy="0"/>
+        </a:xfrm>
+      </p:grpSpPr>
+      <p:pic>
+        <p:nvPicPr>
+          <p:cNvPr id="4" name="Picture 3" descr="A logo with a black background&#10;&#10;AI-generated content may be incorrect.">
+            <a:extLst>
+              <a:ext uri="{FF2B5EF4-FFF2-40B4-BE49-F238E27FC236}">
+                <a16:creationId xmlns:a16="http://schemas.microsoft.com/office/drawing/2014/main" id="{31F86E2F-BCEA-C4BB-1171-4FDE24B88263}"/>
+              </a:ext>
+            </a:extLst>
+          </p:cNvPr>
+          <p:cNvPicPr>
+            <a:picLocks noChangeAspect="1"/>
+          </p:cNvPicPr>
+          <p:nvPr/>
+        </p:nvPicPr>
+        <p:blipFill>
+          <a:blip r:embed="rId3"/>
+          <a:stretch>
+            <a:fillRect/>
+          </a:stretch>
+        </p:blipFill>
+        <p:spPr>
+          <a:xfrm>
+            <a:off x="2851076" y="6019409"/>
+            <a:ext cx="993599" cy="719503"/>
+          </a:xfrm>
+          <a:prstGeom prst="rect">
+            <a:avLst/>
+          </a:prstGeom>
+        </p:spPr>
+      </p:pic>
+      <p:pic>
+        <p:nvPicPr>
+          <p:cNvPr id="10" name="Picture 9" descr="A close up of a logo&#10;&#10;AI-generated content may be incorrect.">
+            <a:extLst>
+              <a:ext uri="{FF2B5EF4-FFF2-40B4-BE49-F238E27FC236}">
+                <a16:creationId xmlns:a16="http://schemas.microsoft.com/office/drawing/2014/main" id="{D4F2F83C-36B2-D682-71AD-E0487FCA7CCA}"/>
+              </a:ext>
+            </a:extLst>
+          </p:cNvPr>
+          <p:cNvPicPr>
+            <a:picLocks noChangeAspect="1"/>
+          </p:cNvPicPr>
+          <p:nvPr/>
+        </p:nvPicPr>
+        <p:blipFill>
+          <a:blip r:embed="rId4"/>
+          <a:stretch>
+            <a:fillRect/>
+          </a:stretch>
+        </p:blipFill>
+        <p:spPr>
+          <a:xfrm>
+            <a:off x="167702" y="6019409"/>
+            <a:ext cx="2214000" cy="719745"/>
+          </a:xfrm>
+          <a:prstGeom prst="rect">
+            <a:avLst/>
+          </a:prstGeom>
+        </p:spPr>
+      </p:pic>
+      <p:grpSp>
+        <p:nvGrpSpPr>
+          <p:cNvPr id="11" name="Group 10">
+            <a:extLst>
+              <a:ext uri="{FF2B5EF4-FFF2-40B4-BE49-F238E27FC236}">
+                <a16:creationId xmlns:a16="http://schemas.microsoft.com/office/drawing/2014/main" id="{80858BE4-B4AD-3121-8A9D-14F098327D5B}"/>
+              </a:ext>
+            </a:extLst>
+          </p:cNvPr>
+          <p:cNvGrpSpPr/>
+          <p:nvPr/>
+        </p:nvGrpSpPr>
+        <p:grpSpPr>
+          <a:xfrm>
+            <a:off x="167702" y="182886"/>
+            <a:ext cx="2742058" cy="720263"/>
+            <a:chOff x="167702" y="346151"/>
+            <a:chExt cx="2742058" cy="720263"/>
+          </a:xfrm>
+        </p:grpSpPr>
+        <p:pic>
+          <p:nvPicPr>
+            <p:cNvPr id="5" name="Picture 4" descr="A logo on a black background&#10;&#10;AI-generated content may be incorrect.">
+              <a:extLst>
+                <a:ext uri="{FF2B5EF4-FFF2-40B4-BE49-F238E27FC236}">
+                  <a16:creationId xmlns:a16="http://schemas.microsoft.com/office/drawing/2014/main" id="{8A6DC6AE-ECDE-9218-441F-9ECD77A1B3B7}"/>
+                </a:ext>
+              </a:extLst>
+            </p:cNvPr>
+            <p:cNvPicPr>
+              <a:picLocks noChangeAspect="1"/>
+            </p:cNvPicPr>
+            <p:nvPr/>
+          </p:nvPicPr>
+          <p:blipFill>
+            <a:blip r:embed="rId5"/>
+            <a:stretch>
+              <a:fillRect/>
+            </a:stretch>
+          </p:blipFill>
+          <p:spPr>
+            <a:xfrm>
+              <a:off x="167702" y="346151"/>
+              <a:ext cx="691200" cy="719412"/>
+            </a:xfrm>
+            <a:prstGeom prst="rect">
+              <a:avLst/>
+            </a:prstGeom>
+          </p:spPr>
+        </p:pic>
+        <p:pic>
+          <p:nvPicPr>
+            <p:cNvPr id="14" name="Picture 13" descr="A logo with blue circles&#10;&#10;AI-generated content may be incorrect.">
+              <a:extLst>
+                <a:ext uri="{FF2B5EF4-FFF2-40B4-BE49-F238E27FC236}">
+                  <a16:creationId xmlns:a16="http://schemas.microsoft.com/office/drawing/2014/main" id="{59F88A86-7A35-24BA-C977-544468A873A4}"/>
+                </a:ext>
+              </a:extLst>
+            </p:cNvPr>
+            <p:cNvPicPr>
+              <a:picLocks noChangeAspect="1"/>
+            </p:cNvPicPr>
+            <p:nvPr/>
+          </p:nvPicPr>
+          <p:blipFill>
+            <a:blip r:embed="rId6"/>
+            <a:stretch>
+              <a:fillRect/>
+            </a:stretch>
+          </p:blipFill>
+          <p:spPr>
+            <a:xfrm>
+              <a:off x="638160" y="346151"/>
+              <a:ext cx="2271600" cy="720263"/>
+            </a:xfrm>
+            <a:prstGeom prst="rect">
+              <a:avLst/>
+            </a:prstGeom>
+          </p:spPr>
+        </p:pic>
+      </p:grpSp>
+      <p:pic>
+        <p:nvPicPr>
+          <p:cNvPr id="2" name="Google Shape;101;p1" descr="A blue and white logo&#10;&#10;Description automatically generated">
+            <a:extLst>
+              <a:ext uri="{FF2B5EF4-FFF2-40B4-BE49-F238E27FC236}">
+                <a16:creationId xmlns:a16="http://schemas.microsoft.com/office/drawing/2014/main" id="{74F56B6D-2C3B-51A0-9683-DC0A1FD59182}"/>
+              </a:ext>
+            </a:extLst>
+          </p:cNvPr>
+          <p:cNvPicPr preferRelativeResize="0"/>
+          <p:nvPr/>
+        </p:nvPicPr>
+        <p:blipFill rotWithShape="1">
+          <a:blip r:embed="rId7">
+            <a:alphaModFix/>
+          </a:blip>
+          <a:srcRect/>
+          <a:stretch/>
+        </p:blipFill>
+        <p:spPr>
+          <a:xfrm>
+            <a:off x="3608587" y="119088"/>
+            <a:ext cx="883778" cy="883778"/>
+          </a:xfrm>
+          <a:prstGeom prst="rect">
+            <a:avLst/>
+          </a:prstGeom>
+          <a:noFill/>
+          <a:ln>
+            <a:noFill/>
+          </a:ln>
+        </p:spPr>
+      </p:pic>
+      <p:pic>
+        <p:nvPicPr>
+          <p:cNvPr id="3" name="Google Shape;104;p1" descr="JCU: James Cook University">
+            <a:extLst>
+              <a:ext uri="{FF2B5EF4-FFF2-40B4-BE49-F238E27FC236}">
+                <a16:creationId xmlns:a16="http://schemas.microsoft.com/office/drawing/2014/main" id="{432C6528-E949-4B01-7E3C-63911022CB19}"/>
+              </a:ext>
+            </a:extLst>
+          </p:cNvPr>
+          <p:cNvPicPr preferRelativeResize="0"/>
+          <p:nvPr/>
+        </p:nvPicPr>
+        <p:blipFill rotWithShape="1">
+          <a:blip r:embed="rId8">
+            <a:alphaModFix/>
+          </a:blip>
+          <a:srcRect/>
+          <a:stretch/>
+        </p:blipFill>
+        <p:spPr>
+          <a:xfrm>
+            <a:off x="5191192" y="119088"/>
+            <a:ext cx="883778" cy="919933"/>
+          </a:xfrm>
+          <a:prstGeom prst="rect">
+            <a:avLst/>
+          </a:prstGeom>
+          <a:noFill/>
+          <a:ln>
+            <a:noFill/>
+          </a:ln>
+        </p:spPr>
+      </p:pic>
+      <p:pic>
+        <p:nvPicPr>
+          <p:cNvPr id="6" name="Picture 5">
+            <a:extLst>
+              <a:ext uri="{FF2B5EF4-FFF2-40B4-BE49-F238E27FC236}">
+                <a16:creationId xmlns:a16="http://schemas.microsoft.com/office/drawing/2014/main" id="{B64A0180-3795-1D1D-BCEE-03819C0F13C7}"/>
+              </a:ext>
+            </a:extLst>
+          </p:cNvPr>
+          <p:cNvPicPr>
+            <a:picLocks noChangeAspect="1"/>
+          </p:cNvPicPr>
+          <p:nvPr/>
+        </p:nvPicPr>
+        <p:blipFill>
+          <a:blip r:embed="rId9"/>
+          <a:stretch>
+            <a:fillRect/>
+          </a:stretch>
+        </p:blipFill>
+        <p:spPr>
+          <a:xfrm>
+            <a:off x="6773797" y="-1148"/>
+            <a:ext cx="2214000" cy="1245375"/>
+          </a:xfrm>
+          <a:prstGeom prst="rect">
+            <a:avLst/>
+          </a:prstGeom>
+        </p:spPr>
+      </p:pic>
+      <p:pic>
+        <p:nvPicPr>
+          <p:cNvPr id="9" name="Picture 8">
+            <a:extLst>
+              <a:ext uri="{FF2B5EF4-FFF2-40B4-BE49-F238E27FC236}">
+                <a16:creationId xmlns:a16="http://schemas.microsoft.com/office/drawing/2014/main" id="{812EAC6A-3D5C-006F-7CA8-05BBCA17742D}"/>
+              </a:ext>
+            </a:extLst>
+          </p:cNvPr>
+          <p:cNvPicPr>
+            <a:picLocks noChangeAspect="1"/>
+          </p:cNvPicPr>
+          <p:nvPr/>
+        </p:nvPicPr>
+        <p:blipFill>
+          <a:blip r:embed="rId10"/>
+          <a:stretch>
+            <a:fillRect/>
+          </a:stretch>
+        </p:blipFill>
+        <p:spPr>
+          <a:xfrm>
+            <a:off x="9686624" y="119088"/>
+            <a:ext cx="2317898" cy="946475"/>
+          </a:xfrm>
+          <a:prstGeom prst="rect">
+            <a:avLst/>
+          </a:prstGeom>
+        </p:spPr>
+      </p:pic>
+    </p:spTree>
+    <p:extLst>
+      <p:ext uri="{BB962C8B-B14F-4D97-AF65-F5344CB8AC3E}">
+        <p14:creationId xmlns:p14="http://schemas.microsoft.com/office/powerpoint/2010/main" val="3407087201"/>
       </p:ext>
     </p:extLst>
   </p:cSld>

</xml_diff>